<commit_message>
Update _FCA_DeepNeuralNework with TensorFlow_lezione.pptx
</commit_message>
<xml_diff>
--- a/_FCA_DeepNeuralNework with TensorFlow_lezione.pptx
+++ b/_FCA_DeepNeuralNework with TensorFlow_lezione.pptx
@@ -5,10 +5,10 @@
     <p:sldMasterId id="2147483648" r:id="rId1"/>
   </p:sldMasterIdLst>
   <p:notesMasterIdLst>
-    <p:notesMasterId r:id="rId16"/>
+    <p:notesMasterId r:id="rId15"/>
   </p:notesMasterIdLst>
   <p:handoutMasterIdLst>
-    <p:handoutMasterId r:id="rId17"/>
+    <p:handoutMasterId r:id="rId16"/>
   </p:handoutMasterIdLst>
   <p:sldIdLst>
     <p:sldId id="286" r:id="rId2"/>
@@ -20,11 +20,10 @@
     <p:sldId id="265" r:id="rId8"/>
     <p:sldId id="262" r:id="rId9"/>
     <p:sldId id="263" r:id="rId10"/>
-    <p:sldId id="291" r:id="rId11"/>
-    <p:sldId id="266" r:id="rId12"/>
-    <p:sldId id="289" r:id="rId13"/>
-    <p:sldId id="288" r:id="rId14"/>
-    <p:sldId id="287" r:id="rId15"/>
+    <p:sldId id="266" r:id="rId11"/>
+    <p:sldId id="288" r:id="rId12"/>
+    <p:sldId id="287" r:id="rId13"/>
+    <p:sldId id="289" r:id="rId14"/>
   </p:sldIdLst>
   <p:sldSz cx="12192000" cy="6858000"/>
   <p:notesSz cx="6858000" cy="9144000"/>
@@ -4089,460 +4088,6 @@
 </file>
 
 <file path=ppt/slides/slide10.xml><?xml version="1.0" encoding="utf-8"?>
-<p:sld xmlns:a="http://schemas.openxmlformats.org/drawingml/2006/main" xmlns:r="http://schemas.openxmlformats.org/officeDocument/2006/relationships" xmlns:p="http://schemas.openxmlformats.org/presentationml/2006/main">
-  <p:cSld>
-    <p:spTree>
-      <p:nvGrpSpPr>
-        <p:cNvPr id="1" name="">
-          <a:extLst>
-            <a:ext uri="{FF2B5EF4-FFF2-40B4-BE49-F238E27FC236}">
-              <a16:creationId xmlns:a16="http://schemas.microsoft.com/office/drawing/2014/main" id="{FB1A0DE0-3271-AE42-3785-DD83F5E22E12}"/>
-            </a:ext>
-          </a:extLst>
-        </p:cNvPr>
-        <p:cNvGrpSpPr/>
-        <p:nvPr/>
-      </p:nvGrpSpPr>
-      <p:grpSpPr>
-        <a:xfrm>
-          <a:off x="0" y="0"/>
-          <a:ext cx="0" cy="0"/>
-          <a:chOff x="0" y="0"/>
-          <a:chExt cx="0" cy="0"/>
-        </a:xfrm>
-      </p:grpSpPr>
-      <p:pic>
-        <p:nvPicPr>
-          <p:cNvPr id="2" name="Immagine 1">
-            <a:extLst>
-              <a:ext uri="{FF2B5EF4-FFF2-40B4-BE49-F238E27FC236}">
-                <a16:creationId xmlns:a16="http://schemas.microsoft.com/office/drawing/2014/main" id="{2C018E7B-0443-D639-DA3F-BBE6BE0161D2}"/>
-              </a:ext>
-            </a:extLst>
-          </p:cNvPr>
-          <p:cNvPicPr>
-            <a:picLocks noChangeAspect="1"/>
-          </p:cNvPicPr>
-          <p:nvPr/>
-        </p:nvPicPr>
-        <p:blipFill>
-          <a:blip r:embed="rId2">
-            <a:extLst>
-              <a:ext uri="{28A0092B-C50C-407E-A947-70E740481C1C}">
-                <a14:useLocalDpi xmlns:a14="http://schemas.microsoft.com/office/drawing/2010/main" val="0"/>
-              </a:ext>
-            </a:extLst>
-          </a:blip>
-          <a:stretch>
-            <a:fillRect/>
-          </a:stretch>
-        </p:blipFill>
-        <p:spPr>
-          <a:xfrm>
-            <a:off x="0" y="3065919"/>
-            <a:ext cx="4732289" cy="3147657"/>
-          </a:xfrm>
-          <a:prstGeom prst="rect">
-            <a:avLst/>
-          </a:prstGeom>
-        </p:spPr>
-      </p:pic>
-      <p:pic>
-        <p:nvPicPr>
-          <p:cNvPr id="62" name="Immagine 61">
-            <a:extLst>
-              <a:ext uri="{FF2B5EF4-FFF2-40B4-BE49-F238E27FC236}">
-                <a16:creationId xmlns:a16="http://schemas.microsoft.com/office/drawing/2014/main" id="{3B2C1CC6-136F-B0A7-4CA2-5785F1DE1561}"/>
-              </a:ext>
-            </a:extLst>
-          </p:cNvPr>
-          <p:cNvPicPr>
-            <a:picLocks noChangeAspect="1"/>
-          </p:cNvPicPr>
-          <p:nvPr/>
-        </p:nvPicPr>
-        <p:blipFill>
-          <a:blip r:embed="rId3">
-            <a:extLst>
-              <a:ext uri="{28A0092B-C50C-407E-A947-70E740481C1C}">
-                <a14:useLocalDpi xmlns:a14="http://schemas.microsoft.com/office/drawing/2010/main" val="0"/>
-              </a:ext>
-            </a:extLst>
-          </a:blip>
-          <a:stretch>
-            <a:fillRect/>
-          </a:stretch>
-        </p:blipFill>
-        <p:spPr>
-          <a:xfrm>
-            <a:off x="889341" y="780495"/>
-            <a:ext cx="3402749" cy="1283672"/>
-          </a:xfrm>
-          <a:prstGeom prst="rect">
-            <a:avLst/>
-          </a:prstGeom>
-        </p:spPr>
-      </p:pic>
-      <p:sp>
-        <p:nvSpPr>
-          <p:cNvPr id="63" name="CasellaDiTesto 62">
-            <a:extLst>
-              <a:ext uri="{FF2B5EF4-FFF2-40B4-BE49-F238E27FC236}">
-                <a16:creationId xmlns:a16="http://schemas.microsoft.com/office/drawing/2014/main" id="{0CC390FC-AC2A-50E6-AFFE-7165DC3D8E43}"/>
-              </a:ext>
-            </a:extLst>
-          </p:cNvPr>
-          <p:cNvSpPr txBox="1"/>
-          <p:nvPr/>
-        </p:nvSpPr>
-        <p:spPr>
-          <a:xfrm>
-            <a:off x="5274748" y="18131"/>
-            <a:ext cx="7082122" cy="4154984"/>
-          </a:xfrm>
-          <a:prstGeom prst="rect">
-            <a:avLst/>
-          </a:prstGeom>
-          <a:noFill/>
-        </p:spPr>
-        <p:txBody>
-          <a:bodyPr wrap="square" rtlCol="0">
-            <a:spAutoFit/>
-          </a:bodyPr>
-          <a:lstStyle/>
-          <a:p>
-            <a:pPr algn="ctr"/>
-            <a:r>
-              <a:rPr lang="en-IN" sz="3200" b="1" noProof="0" dirty="0">
-                <a:latin typeface="Book Antiqua" panose="02040602050305030304" pitchFamily="18" charset="0"/>
-              </a:rPr>
-              <a:t>We will</a:t>
-            </a:r>
-          </a:p>
-          <a:p>
-            <a:pPr algn="ctr"/>
-            <a:endParaRPr lang="it-IT" sz="1200" b="1" dirty="0">
-              <a:latin typeface="Book Antiqua" panose="02040602050305030304" pitchFamily="18" charset="0"/>
-            </a:endParaRPr>
-          </a:p>
-          <a:p>
-            <a:pPr marL="285750" indent="-285750">
-              <a:buFont typeface="Arial" panose="020B0604020202020204" pitchFamily="34" charset="0"/>
-              <a:buChar char="•"/>
-            </a:pPr>
-            <a:r>
-              <a:rPr lang="en-US" sz="2000" dirty="0">
-                <a:latin typeface="Book Antiqua" panose="02040602050305030304" pitchFamily="18" charset="0"/>
-              </a:rPr>
-              <a:t>Build the Deep Learning models (using </a:t>
-            </a:r>
-            <a:r>
-              <a:rPr lang="en-US" sz="2000" dirty="0" err="1">
-                <a:latin typeface="Book Antiqua" panose="02040602050305030304" pitchFamily="18" charset="0"/>
-                <a:hlinkClick r:id="rId4"/>
-              </a:rPr>
-              <a:t>Keras</a:t>
-            </a:r>
-            <a:r>
-              <a:rPr lang="en-US" sz="2000" dirty="0">
-                <a:latin typeface="Book Antiqua" panose="02040602050305030304" pitchFamily="18" charset="0"/>
-              </a:rPr>
-              <a:t>)</a:t>
-            </a:r>
-            <a:br>
-              <a:rPr lang="en-US" sz="2000" dirty="0">
-                <a:latin typeface="Book Antiqua" panose="02040602050305030304" pitchFamily="18" charset="0"/>
-              </a:rPr>
-            </a:br>
-            <a:r>
-              <a:rPr lang="en-US" sz="2000" dirty="0">
-                <a:latin typeface="Book Antiqua" panose="02040602050305030304" pitchFamily="18" charset="0"/>
-              </a:rPr>
-              <a:t>(Deep learning Framework)</a:t>
-            </a:r>
-          </a:p>
-          <a:p>
-            <a:pPr marL="285750" indent="-285750">
-              <a:buFont typeface="Arial" panose="020B0604020202020204" pitchFamily="34" charset="0"/>
-              <a:buChar char="•"/>
-            </a:pPr>
-            <a:endParaRPr lang="en-US" sz="2000" dirty="0">
-              <a:latin typeface="Book Antiqua" panose="02040602050305030304" pitchFamily="18" charset="0"/>
-            </a:endParaRPr>
-          </a:p>
-          <a:p>
-            <a:pPr marL="285750" indent="-285750">
-              <a:buFont typeface="Arial" panose="020B0604020202020204" pitchFamily="34" charset="0"/>
-              <a:buChar char="•"/>
-            </a:pPr>
-            <a:r>
-              <a:rPr lang="en-US" sz="2000" dirty="0">
-                <a:latin typeface="Book Antiqua" panose="02040602050305030304" pitchFamily="18" charset="0"/>
-              </a:rPr>
-              <a:t>Take our first look at </a:t>
-            </a:r>
-            <a:r>
-              <a:rPr lang="en-US" sz="2000" dirty="0">
-                <a:latin typeface="Book Antiqua" panose="02040602050305030304" pitchFamily="18" charset="0"/>
-                <a:hlinkClick r:id="rId5"/>
-              </a:rPr>
-              <a:t>Google </a:t>
-            </a:r>
-            <a:r>
-              <a:rPr lang="en-US" sz="2000" dirty="0" err="1">
-                <a:latin typeface="Book Antiqua" panose="02040602050305030304" pitchFamily="18" charset="0"/>
-                <a:hlinkClick r:id="rId5"/>
-              </a:rPr>
-              <a:t>Colab</a:t>
-            </a:r>
-            <a:r>
-              <a:rPr lang="en-US" sz="2000" dirty="0">
-                <a:latin typeface="Book Antiqua" panose="02040602050305030304" pitchFamily="18" charset="0"/>
-              </a:rPr>
-              <a:t> (</a:t>
-            </a:r>
-            <a:r>
-              <a:rPr lang="en-US" sz="2000" dirty="0">
-                <a:latin typeface="Book Antiqua" panose="02040602050305030304" pitchFamily="18" charset="0"/>
-                <a:hlinkClick r:id="rId6"/>
-              </a:rPr>
-              <a:t>Start with </a:t>
-            </a:r>
-            <a:r>
-              <a:rPr lang="en-US" sz="2000" dirty="0" err="1">
-                <a:latin typeface="Book Antiqua" panose="02040602050305030304" pitchFamily="18" charset="0"/>
-                <a:hlinkClick r:id="rId6"/>
-              </a:rPr>
-              <a:t>Colab</a:t>
-            </a:r>
-            <a:r>
-              <a:rPr lang="en-US" sz="2000" dirty="0">
-                <a:latin typeface="Book Antiqua" panose="02040602050305030304" pitchFamily="18" charset="0"/>
-              </a:rPr>
-              <a:t>)</a:t>
-            </a:r>
-            <a:br>
-              <a:rPr lang="en-US" sz="2000" dirty="0">
-                <a:latin typeface="Book Antiqua" panose="02040602050305030304" pitchFamily="18" charset="0"/>
-              </a:rPr>
-            </a:br>
-            <a:r>
-              <a:rPr lang="en-US" sz="2000" dirty="0">
-                <a:latin typeface="Book Antiqua" panose="02040602050305030304" pitchFamily="18" charset="0"/>
-              </a:rPr>
-              <a:t>(Computational resources offered by Google)</a:t>
-            </a:r>
-          </a:p>
-          <a:p>
-            <a:pPr marL="285750" indent="-285750">
-              <a:buFont typeface="Arial" panose="020B0604020202020204" pitchFamily="34" charset="0"/>
-              <a:buChar char="•"/>
-            </a:pPr>
-            <a:endParaRPr lang="en-US" sz="2000" dirty="0">
-              <a:latin typeface="Book Antiqua" panose="02040602050305030304" pitchFamily="18" charset="0"/>
-            </a:endParaRPr>
-          </a:p>
-          <a:p>
-            <a:pPr marL="285750" indent="-285750">
-              <a:buFont typeface="Arial" panose="020B0604020202020204" pitchFamily="34" charset="0"/>
-              <a:buChar char="•"/>
-            </a:pPr>
-            <a:r>
-              <a:rPr lang="en-US" sz="2000" dirty="0">
-                <a:latin typeface="Book Antiqua" panose="02040602050305030304" pitchFamily="18" charset="0"/>
-              </a:rPr>
-              <a:t>Run Python in </a:t>
-            </a:r>
-            <a:r>
-              <a:rPr lang="en-US" sz="2000" dirty="0">
-                <a:latin typeface="Book Antiqua" panose="02040602050305030304" pitchFamily="18" charset="0"/>
-                <a:hlinkClick r:id="rId7"/>
-              </a:rPr>
-              <a:t>notebooks</a:t>
-            </a:r>
-            <a:br>
-              <a:rPr lang="en-US" sz="2000" dirty="0">
-                <a:latin typeface="Book Antiqua" panose="02040602050305030304" pitchFamily="18" charset="0"/>
-              </a:rPr>
-            </a:br>
-            <a:r>
-              <a:rPr lang="en-US" sz="2000" dirty="0">
-                <a:latin typeface="Book Antiqua" panose="02040602050305030304" pitchFamily="18" charset="0"/>
-              </a:rPr>
-              <a:t>(Way to run python interactively)</a:t>
-            </a:r>
-          </a:p>
-          <a:p>
-            <a:endParaRPr lang="en-US" sz="2000" dirty="0">
-              <a:latin typeface="Book Antiqua" panose="02040602050305030304" pitchFamily="18" charset="0"/>
-            </a:endParaRPr>
-          </a:p>
-          <a:p>
-            <a:pPr marL="285750" indent="-285750">
-              <a:buFont typeface="Arial" panose="020B0604020202020204" pitchFamily="34" charset="0"/>
-              <a:buChar char="•"/>
-            </a:pPr>
-            <a:r>
-              <a:rPr lang="en-US" sz="2000" dirty="0">
-                <a:latin typeface="Book Antiqua" panose="02040602050305030304" pitchFamily="18" charset="0"/>
-              </a:rPr>
-              <a:t>Have our first interaction with </a:t>
-            </a:r>
-            <a:r>
-              <a:rPr lang="en-US" sz="2000" dirty="0">
-                <a:latin typeface="Book Antiqua" panose="02040602050305030304" pitchFamily="18" charset="0"/>
-                <a:hlinkClick r:id="rId8"/>
-              </a:rPr>
-              <a:t>GitHub</a:t>
-            </a:r>
-            <a:r>
-              <a:rPr lang="en-US" sz="2000" dirty="0">
-                <a:latin typeface="Book Antiqua" panose="02040602050305030304" pitchFamily="18" charset="0"/>
-              </a:rPr>
-              <a:t> </a:t>
-            </a:r>
-            <a:br>
-              <a:rPr lang="en-US" sz="2000" dirty="0">
-                <a:latin typeface="Book Antiqua" panose="02040602050305030304" pitchFamily="18" charset="0"/>
-              </a:rPr>
-            </a:br>
-            <a:r>
-              <a:rPr lang="en-US" sz="2000" dirty="0">
-                <a:latin typeface="Book Antiqua" panose="02040602050305030304" pitchFamily="18" charset="0"/>
-              </a:rPr>
-              <a:t>(repositories “folders” to store and share code)</a:t>
-            </a:r>
-            <a:endParaRPr lang="it-IT" sz="2000" dirty="0">
-              <a:latin typeface="Book Antiqua" panose="02040602050305030304" pitchFamily="18" charset="0"/>
-            </a:endParaRPr>
-          </a:p>
-        </p:txBody>
-      </p:sp>
-      <p:sp>
-        <p:nvSpPr>
-          <p:cNvPr id="3" name="CasellaDiTesto 2">
-            <a:extLst>
-              <a:ext uri="{FF2B5EF4-FFF2-40B4-BE49-F238E27FC236}">
-                <a16:creationId xmlns:a16="http://schemas.microsoft.com/office/drawing/2014/main" id="{DA60874C-8821-1BFE-32E1-20CBB25D6854}"/>
-              </a:ext>
-            </a:extLst>
-          </p:cNvPr>
-          <p:cNvSpPr txBox="1"/>
-          <p:nvPr/>
-        </p:nvSpPr>
-        <p:spPr>
-          <a:xfrm>
-            <a:off x="4974517" y="4495690"/>
-            <a:ext cx="7235955" cy="1938992"/>
-          </a:xfrm>
-          <a:prstGeom prst="rect">
-            <a:avLst/>
-          </a:prstGeom>
-          <a:noFill/>
-        </p:spPr>
-        <p:txBody>
-          <a:bodyPr wrap="none" rtlCol="0">
-            <a:spAutoFit/>
-          </a:bodyPr>
-          <a:lstStyle/>
-          <a:p>
-            <a:r>
-              <a:rPr lang="en-ZW" sz="2400" dirty="0">
-                <a:latin typeface="Calibri" panose="020F0502020204030204" pitchFamily="34" charset="0"/>
-                <a:cs typeface="Calibri" panose="020F0502020204030204" pitchFamily="34" charset="0"/>
-              </a:rPr>
-              <a:t>All the material is loaded in </a:t>
-            </a:r>
-            <a:r>
-              <a:rPr lang="en-ZW" sz="2400" dirty="0">
-                <a:latin typeface="Calibri" panose="020F0502020204030204" pitchFamily="34" charset="0"/>
-                <a:cs typeface="Calibri" panose="020F0502020204030204" pitchFamily="34" charset="0"/>
-                <a:hlinkClick r:id="rId9"/>
-              </a:rPr>
-              <a:t>this folder</a:t>
-            </a:r>
-            <a:r>
-              <a:rPr lang="en-ZW" sz="2400" dirty="0">
-                <a:latin typeface="Calibri" panose="020F0502020204030204" pitchFamily="34" charset="0"/>
-                <a:cs typeface="Calibri" panose="020F0502020204030204" pitchFamily="34" charset="0"/>
-              </a:rPr>
-              <a:t>. </a:t>
-            </a:r>
-          </a:p>
-          <a:p>
-            <a:r>
-              <a:rPr lang="en-ZW" sz="2400" dirty="0">
-                <a:latin typeface="Calibri" panose="020F0502020204030204" pitchFamily="34" charset="0"/>
-                <a:cs typeface="Calibri" panose="020F0502020204030204" pitchFamily="34" charset="0"/>
-              </a:rPr>
-              <a:t>The useful files are:</a:t>
-            </a:r>
-          </a:p>
-          <a:p>
-            <a:r>
-              <a:rPr lang="en-US" sz="2400" dirty="0">
-                <a:latin typeface="Calibri" panose="020F0502020204030204" pitchFamily="34" charset="0"/>
-                <a:cs typeface="Calibri" panose="020F0502020204030204" pitchFamily="34" charset="0"/>
-              </a:rPr>
-              <a:t>_</a:t>
-            </a:r>
-            <a:r>
-              <a:rPr lang="en-US" sz="2400" dirty="0" err="1">
-                <a:latin typeface="Calibri" panose="020F0502020204030204" pitchFamily="34" charset="0"/>
-                <a:cs typeface="Calibri" panose="020F0502020204030204" pitchFamily="34" charset="0"/>
-              </a:rPr>
-              <a:t>SNS_DeepNeuralNework</a:t>
-            </a:r>
-            <a:r>
-              <a:rPr lang="en-US" sz="2400" dirty="0">
-                <a:latin typeface="Calibri" panose="020F0502020204030204" pitchFamily="34" charset="0"/>
-                <a:cs typeface="Calibri" panose="020F0502020204030204" pitchFamily="34" charset="0"/>
-              </a:rPr>
-              <a:t> with TensorFlow_lezione.pptx</a:t>
-            </a:r>
-          </a:p>
-          <a:p>
-            <a:r>
-              <a:rPr lang="en-ZW" sz="2400" dirty="0" err="1">
-                <a:latin typeface="Calibri" panose="020F0502020204030204" pitchFamily="34" charset="0"/>
-                <a:cs typeface="Calibri" panose="020F0502020204030204" pitchFamily="34" charset="0"/>
-              </a:rPr>
-              <a:t>Deep_Dense_MNIST.ipynb</a:t>
-            </a:r>
-            <a:endParaRPr lang="en-ZW" sz="2400" dirty="0">
-              <a:latin typeface="Calibri" panose="020F0502020204030204" pitchFamily="34" charset="0"/>
-              <a:cs typeface="Calibri" panose="020F0502020204030204" pitchFamily="34" charset="0"/>
-            </a:endParaRPr>
-          </a:p>
-          <a:p>
-            <a:r>
-              <a:rPr lang="en-ZW" sz="2400" dirty="0" err="1">
-                <a:latin typeface="Calibri" panose="020F0502020204030204" pitchFamily="34" charset="0"/>
-                <a:cs typeface="Calibri" panose="020F0502020204030204" pitchFamily="34" charset="0"/>
-              </a:rPr>
-              <a:t>Deep_Convolutional_MNIST.ipynb</a:t>
-            </a:r>
-            <a:endParaRPr lang="en-ZW" sz="2400" noProof="0" dirty="0">
-              <a:latin typeface="Calibri" panose="020F0502020204030204" pitchFamily="34" charset="0"/>
-              <a:cs typeface="Calibri" panose="020F0502020204030204" pitchFamily="34" charset="0"/>
-            </a:endParaRPr>
-          </a:p>
-        </p:txBody>
-      </p:sp>
-    </p:spTree>
-    <p:extLst>
-      <p:ext uri="{BB962C8B-B14F-4D97-AF65-F5344CB8AC3E}">
-        <p14:creationId xmlns:p14="http://schemas.microsoft.com/office/powerpoint/2010/main" val="2639309574"/>
-      </p:ext>
-    </p:extLst>
-  </p:cSld>
-  <p:clrMapOvr>
-    <a:masterClrMapping/>
-  </p:clrMapOvr>
-</p:sld>
-</file>
-
-<file path=ppt/slides/slide11.xml><?xml version="1.0" encoding="utf-8"?>
 <p:sld xmlns:a="http://schemas.openxmlformats.org/drawingml/2006/main" xmlns:r="http://schemas.openxmlformats.org/officeDocument/2006/relationships" xmlns:p="http://schemas.openxmlformats.org/presentationml/2006/main">
   <p:cSld>
     <p:spTree>
@@ -6536,771 +6081,7 @@
 </p:sld>
 </file>
 
-<file path=ppt/slides/slide12.xml><?xml version="1.0" encoding="utf-8"?>
-<p:sld xmlns:a="http://schemas.openxmlformats.org/drawingml/2006/main" xmlns:r="http://schemas.openxmlformats.org/officeDocument/2006/relationships" xmlns:p="http://schemas.openxmlformats.org/presentationml/2006/main" show="0">
-  <p:cSld>
-    <p:spTree>
-      <p:nvGrpSpPr>
-        <p:cNvPr id="1" name=""/>
-        <p:cNvGrpSpPr/>
-        <p:nvPr/>
-      </p:nvGrpSpPr>
-      <p:grpSpPr>
-        <a:xfrm>
-          <a:off x="0" y="0"/>
-          <a:ext cx="0" cy="0"/>
-          <a:chOff x="0" y="0"/>
-          <a:chExt cx="0" cy="0"/>
-        </a:xfrm>
-      </p:grpSpPr>
-      <p:pic>
-        <p:nvPicPr>
-          <p:cNvPr id="9" name="Immagine 8">
-            <a:extLst>
-              <a:ext uri="{FF2B5EF4-FFF2-40B4-BE49-F238E27FC236}">
-                <a16:creationId xmlns:a16="http://schemas.microsoft.com/office/drawing/2014/main" id="{426D9FD0-5E7A-806F-7738-F5C179FB2CE4}"/>
-              </a:ext>
-            </a:extLst>
-          </p:cNvPr>
-          <p:cNvPicPr>
-            <a:picLocks noChangeAspect="1"/>
-          </p:cNvPicPr>
-          <p:nvPr/>
-        </p:nvPicPr>
-        <p:blipFill>
-          <a:blip r:embed="rId2">
-            <a:extLst>
-              <a:ext uri="{28A0092B-C50C-407E-A947-70E740481C1C}">
-                <a14:useLocalDpi xmlns:a14="http://schemas.microsoft.com/office/drawing/2010/main" val="0"/>
-              </a:ext>
-            </a:extLst>
-          </a:blip>
-          <a:stretch>
-            <a:fillRect/>
-          </a:stretch>
-        </p:blipFill>
-        <p:spPr>
-          <a:xfrm>
-            <a:off x="1202038" y="1039929"/>
-            <a:ext cx="5433531" cy="3101609"/>
-          </a:xfrm>
-          <a:prstGeom prst="rect">
-            <a:avLst/>
-          </a:prstGeom>
-        </p:spPr>
-      </p:pic>
-      <mc:AlternateContent xmlns:mc="http://schemas.openxmlformats.org/markup-compatibility/2006" xmlns:a14="http://schemas.microsoft.com/office/drawing/2010/main">
-        <mc:Choice Requires="a14">
-          <p:sp>
-            <p:nvSpPr>
-              <p:cNvPr id="5" name="CasellaDiTesto 4">
-                <a:extLst>
-                  <a:ext uri="{FF2B5EF4-FFF2-40B4-BE49-F238E27FC236}">
-                    <a16:creationId xmlns:a16="http://schemas.microsoft.com/office/drawing/2014/main" id="{DE26804E-933A-AEFF-94B0-1FF2B1F505FE}"/>
-                  </a:ext>
-                </a:extLst>
-              </p:cNvPr>
-              <p:cNvSpPr txBox="1"/>
-              <p:nvPr/>
-            </p:nvSpPr>
-            <p:spPr>
-              <a:xfrm>
-                <a:off x="1592795" y="4204527"/>
-                <a:ext cx="7121934" cy="1815882"/>
-              </a:xfrm>
-              <a:prstGeom prst="rect">
-                <a:avLst/>
-              </a:prstGeom>
-              <a:noFill/>
-            </p:spPr>
-            <p:txBody>
-              <a:bodyPr wrap="square" rtlCol="0">
-                <a:spAutoFit/>
-              </a:bodyPr>
-              <a:lstStyle/>
-              <a:p>
-                <a:pPr marL="342900" indent="-342900">
-                  <a:buFont typeface="Arial" panose="020B0604020202020204" pitchFamily="34" charset="0"/>
-                  <a:buChar char="•"/>
-                </a:pPr>
-                <a:r>
-                  <a:rPr lang="en-PH" sz="2400" b="1" dirty="0"/>
-                  <a:t>Sparse connectivity </a:t>
-                </a:r>
-                <a:r>
-                  <a:rPr lang="en-PH" sz="2400" dirty="0"/>
-                  <a:t>-</a:t>
-                </a:r>
-                <a:r>
-                  <a:rPr lang="en-PH" sz="2000" dirty="0"/>
-                  <a:t>&gt; retrieve spatial information</a:t>
-                </a:r>
-                <a:endParaRPr lang="en-PH" sz="2400" dirty="0"/>
-              </a:p>
-              <a:p>
-                <a:endParaRPr lang="en-PH" sz="2400" b="1" dirty="0"/>
-              </a:p>
-              <a:p>
-                <a:pPr marL="342900" indent="-342900">
-                  <a:buFont typeface="Arial" panose="020B0604020202020204" pitchFamily="34" charset="0"/>
-                  <a:buChar char="•"/>
-                </a:pPr>
-                <a:r>
-                  <a:rPr lang="en-PH" sz="2400" b="1" dirty="0"/>
-                  <a:t>Weight sharing </a:t>
-                </a:r>
-                <a:r>
-                  <a:rPr lang="en-PH" sz="2400" dirty="0"/>
-                  <a:t>-------</a:t>
-                </a:r>
-                <a:r>
-                  <a:rPr lang="en-PH" sz="2000" dirty="0"/>
-                  <a:t>&gt; Translational invariance</a:t>
-                </a:r>
-              </a:p>
-              <a:p>
-                <a:pPr lvl="1"/>
-                <a:r>
-                  <a:rPr lang="en-PH" sz="2000" dirty="0"/>
-                  <a:t>    (</a:t>
-                </a:r>
-                <a14:m>
-                  <m:oMath xmlns:m="http://schemas.openxmlformats.org/officeDocument/2006/math">
-                    <m:sSub>
-                      <m:sSubPr>
-                        <m:ctrlPr>
-                          <a:rPr lang="it-IT" sz="2000" i="1">
-                            <a:latin typeface="Cambria Math" panose="02040503050406030204" pitchFamily="18" charset="0"/>
-                          </a:rPr>
-                        </m:ctrlPr>
-                      </m:sSubPr>
-                      <m:e>
-                        <m:r>
-                          <a:rPr lang="it-IT" sz="2000" i="1">
-                            <a:latin typeface="Cambria Math" panose="02040503050406030204" pitchFamily="18" charset="0"/>
-                          </a:rPr>
-                          <m:t>𝑤</m:t>
-                        </m:r>
-                      </m:e>
-                      <m:sub>
-                        <m:r>
-                          <a:rPr lang="it-IT" sz="2000" i="1">
-                            <a:latin typeface="Cambria Math" panose="02040503050406030204" pitchFamily="18" charset="0"/>
-                          </a:rPr>
-                          <m:t>1</m:t>
-                        </m:r>
-                      </m:sub>
-                    </m:sSub>
-                    <m:r>
-                      <a:rPr lang="it-IT" sz="2000" i="1">
-                        <a:latin typeface="Cambria Math" panose="02040503050406030204" pitchFamily="18" charset="0"/>
-                      </a:rPr>
-                      <m:t>=</m:t>
-                    </m:r>
-                    <m:sSub>
-                      <m:sSubPr>
-                        <m:ctrlPr>
-                          <a:rPr lang="it-IT" sz="2000" i="1">
-                            <a:latin typeface="Cambria Math" panose="02040503050406030204" pitchFamily="18" charset="0"/>
-                          </a:rPr>
-                        </m:ctrlPr>
-                      </m:sSubPr>
-                      <m:e>
-                        <m:r>
-                          <a:rPr lang="it-IT" sz="2000" i="1">
-                            <a:latin typeface="Cambria Math" panose="02040503050406030204" pitchFamily="18" charset="0"/>
-                          </a:rPr>
-                          <m:t>𝑤</m:t>
-                        </m:r>
-                      </m:e>
-                      <m:sub>
-                        <m:r>
-                          <a:rPr lang="it-IT" sz="2000" i="1">
-                            <a:latin typeface="Cambria Math" panose="02040503050406030204" pitchFamily="18" charset="0"/>
-                          </a:rPr>
-                          <m:t>2</m:t>
-                        </m:r>
-                      </m:sub>
-                    </m:sSub>
-                  </m:oMath>
-                </a14:m>
-                <a:r>
-                  <a:rPr lang="en-PH" sz="2000" dirty="0"/>
-                  <a:t>)</a:t>
-                </a:r>
-                <a:endParaRPr lang="it-IT" sz="2000" dirty="0"/>
-              </a:p>
-              <a:p>
-                <a:pPr lvl="1"/>
-                <a:endParaRPr lang="en-PH" sz="2000" dirty="0"/>
-              </a:p>
-            </p:txBody>
-          </p:sp>
-        </mc:Choice>
-        <mc:Fallback xmlns="">
-          <p:sp>
-            <p:nvSpPr>
-              <p:cNvPr id="5" name="CasellaDiTesto 4">
-                <a:extLst>
-                  <a:ext uri="{FF2B5EF4-FFF2-40B4-BE49-F238E27FC236}">
-                    <a16:creationId xmlns:a16="http://schemas.microsoft.com/office/drawing/2014/main" id="{DE26804E-933A-AEFF-94B0-1FF2B1F505FE}"/>
-                  </a:ext>
-                </a:extLst>
-              </p:cNvPr>
-              <p:cNvSpPr txBox="1">
-                <a:spLocks noRot="1" noChangeAspect="1" noMove="1" noResize="1" noEditPoints="1" noAdjustHandles="1" noChangeArrowheads="1" noChangeShapeType="1" noTextEdit="1"/>
-              </p:cNvSpPr>
-              <p:nvPr/>
-            </p:nvSpPr>
-            <p:spPr>
-              <a:xfrm>
-                <a:off x="1592795" y="4204527"/>
-                <a:ext cx="7121934" cy="1815882"/>
-              </a:xfrm>
-              <a:prstGeom prst="rect">
-                <a:avLst/>
-              </a:prstGeom>
-              <a:blipFill>
-                <a:blip r:embed="rId3"/>
-                <a:stretch>
-                  <a:fillRect l="-1112" t="-2349"/>
-                </a:stretch>
-              </a:blipFill>
-            </p:spPr>
-            <p:txBody>
-              <a:bodyPr/>
-              <a:lstStyle/>
-              <a:p>
-                <a:r>
-                  <a:rPr lang="it-IT">
-                    <a:noFill/>
-                  </a:rPr>
-                  <a:t> </a:t>
-                </a:r>
-              </a:p>
-            </p:txBody>
-          </p:sp>
-        </mc:Fallback>
-      </mc:AlternateContent>
-      <mc:AlternateContent xmlns:mc="http://schemas.openxmlformats.org/markup-compatibility/2006" xmlns:a14="http://schemas.microsoft.com/office/drawing/2010/main">
-        <mc:Choice Requires="a14">
-          <p:sp>
-            <p:nvSpPr>
-              <p:cNvPr id="19" name="CasellaDiTesto 18">
-                <a:extLst>
-                  <a:ext uri="{FF2B5EF4-FFF2-40B4-BE49-F238E27FC236}">
-                    <a16:creationId xmlns:a16="http://schemas.microsoft.com/office/drawing/2014/main" id="{BF2604CA-475F-259C-6DDC-F1F5D1F66FA5}"/>
-                  </a:ext>
-                </a:extLst>
-              </p:cNvPr>
-              <p:cNvSpPr txBox="1"/>
-              <p:nvPr/>
-            </p:nvSpPr>
-            <p:spPr>
-              <a:xfrm>
-                <a:off x="2254112" y="2668378"/>
-                <a:ext cx="567783" cy="523220"/>
-              </a:xfrm>
-              <a:prstGeom prst="rect">
-                <a:avLst/>
-              </a:prstGeom>
-              <a:noFill/>
-            </p:spPr>
-            <p:txBody>
-              <a:bodyPr wrap="none" rtlCol="0">
-                <a:spAutoFit/>
-              </a:bodyPr>
-              <a:lstStyle/>
-              <a:p>
-                <a:pPr/>
-                <a14:m>
-                  <m:oMathPara xmlns:m="http://schemas.openxmlformats.org/officeDocument/2006/math">
-                    <m:oMathParaPr>
-                      <m:jc m:val="centerGroup"/>
-                    </m:oMathParaPr>
-                    <m:oMath xmlns:m="http://schemas.openxmlformats.org/officeDocument/2006/math">
-                      <m:r>
-                        <a:rPr lang="it-IT" sz="2800" b="1" i="1" smtClean="0">
-                          <a:solidFill>
-                            <a:srgbClr val="1F4291"/>
-                          </a:solidFill>
-                          <a:latin typeface="Cambria Math" panose="02040503050406030204" pitchFamily="18" charset="0"/>
-                        </a:rPr>
-                        <m:t>𝒘</m:t>
-                      </m:r>
-                    </m:oMath>
-                  </m:oMathPara>
-                </a14:m>
-                <a:endParaRPr lang="it-IT" b="1" dirty="0">
-                  <a:solidFill>
-                    <a:srgbClr val="1F4291"/>
-                  </a:solidFill>
-                </a:endParaRPr>
-              </a:p>
-            </p:txBody>
-          </p:sp>
-        </mc:Choice>
-        <mc:Fallback xmlns="">
-          <p:sp>
-            <p:nvSpPr>
-              <p:cNvPr id="19" name="CasellaDiTesto 18">
-                <a:extLst>
-                  <a:ext uri="{FF2B5EF4-FFF2-40B4-BE49-F238E27FC236}">
-                    <a16:creationId xmlns:a16="http://schemas.microsoft.com/office/drawing/2014/main" id="{BF2604CA-475F-259C-6DDC-F1F5D1F66FA5}"/>
-                  </a:ext>
-                </a:extLst>
-              </p:cNvPr>
-              <p:cNvSpPr txBox="1">
-                <a:spLocks noRot="1" noChangeAspect="1" noMove="1" noResize="1" noEditPoints="1" noAdjustHandles="1" noChangeArrowheads="1" noChangeShapeType="1" noTextEdit="1"/>
-              </p:cNvSpPr>
-              <p:nvPr/>
-            </p:nvSpPr>
-            <p:spPr>
-              <a:xfrm>
-                <a:off x="2254112" y="2668378"/>
-                <a:ext cx="567783" cy="523220"/>
-              </a:xfrm>
-              <a:prstGeom prst="rect">
-                <a:avLst/>
-              </a:prstGeom>
-              <a:blipFill>
-                <a:blip r:embed="rId4"/>
-                <a:stretch>
-                  <a:fillRect/>
-                </a:stretch>
-              </a:blipFill>
-            </p:spPr>
-            <p:txBody>
-              <a:bodyPr/>
-              <a:lstStyle/>
-              <a:p>
-                <a:r>
-                  <a:rPr lang="it-IT">
-                    <a:noFill/>
-                  </a:rPr>
-                  <a:t> </a:t>
-                </a:r>
-              </a:p>
-            </p:txBody>
-          </p:sp>
-        </mc:Fallback>
-      </mc:AlternateContent>
-      <p:sp>
-        <p:nvSpPr>
-          <p:cNvPr id="23" name="CasellaDiTesto 22">
-            <a:extLst>
-              <a:ext uri="{FF2B5EF4-FFF2-40B4-BE49-F238E27FC236}">
-                <a16:creationId xmlns:a16="http://schemas.microsoft.com/office/drawing/2014/main" id="{B6577D95-5E14-FE86-3DAE-77C5FC179719}"/>
-              </a:ext>
-            </a:extLst>
-          </p:cNvPr>
-          <p:cNvSpPr txBox="1"/>
-          <p:nvPr/>
-        </p:nvSpPr>
-        <p:spPr>
-          <a:xfrm>
-            <a:off x="0" y="350575"/>
-            <a:ext cx="12192000" cy="830997"/>
-          </a:xfrm>
-          <a:prstGeom prst="rect">
-            <a:avLst/>
-          </a:prstGeom>
-          <a:noFill/>
-        </p:spPr>
-        <p:txBody>
-          <a:bodyPr wrap="square" rtlCol="0">
-            <a:spAutoFit/>
-          </a:bodyPr>
-          <a:lstStyle/>
-          <a:p>
-            <a:pPr algn="ctr"/>
-            <a:r>
-              <a:rPr lang="en-PH" sz="2400" dirty="0"/>
-              <a:t>Convolutional Neural </a:t>
-            </a:r>
-            <a:r>
-              <a:rPr lang="en-PH" sz="2400" dirty="0" err="1"/>
-              <a:t>Netowrks</a:t>
-            </a:r>
-            <a:endParaRPr lang="en-PH" sz="2400" dirty="0"/>
-          </a:p>
-          <a:p>
-            <a:pPr algn="ctr"/>
-            <a:r>
-              <a:rPr lang="en-PH" sz="2400" dirty="0"/>
-              <a:t>(CNNs)</a:t>
-            </a:r>
-            <a:endParaRPr lang="en-PH" sz="2000" dirty="0"/>
-          </a:p>
-        </p:txBody>
-      </p:sp>
-      <p:sp>
-        <p:nvSpPr>
-          <p:cNvPr id="4" name="CasellaDiTesto 3">
-            <a:extLst>
-              <a:ext uri="{FF2B5EF4-FFF2-40B4-BE49-F238E27FC236}">
-                <a16:creationId xmlns:a16="http://schemas.microsoft.com/office/drawing/2014/main" id="{6DD8B2EA-EBF4-A2B5-87A3-3B5D812DB12C}"/>
-              </a:ext>
-            </a:extLst>
-          </p:cNvPr>
-          <p:cNvSpPr txBox="1"/>
-          <p:nvPr/>
-        </p:nvSpPr>
-        <p:spPr>
-          <a:xfrm>
-            <a:off x="184961" y="6020409"/>
-            <a:ext cx="3172663" cy="646331"/>
-          </a:xfrm>
-          <a:prstGeom prst="rect">
-            <a:avLst/>
-          </a:prstGeom>
-          <a:noFill/>
-        </p:spPr>
-        <p:txBody>
-          <a:bodyPr wrap="none" rtlCol="0">
-            <a:spAutoFit/>
-          </a:bodyPr>
-          <a:lstStyle/>
-          <a:p>
-            <a:pPr algn="ctr"/>
-            <a:r>
-              <a:rPr lang="it-IT" dirty="0"/>
-              <a:t>Book</a:t>
-            </a:r>
-          </a:p>
-          <a:p>
-            <a:r>
-              <a:rPr lang="it-IT" dirty="0">
-                <a:hlinkClick r:id="rId5"/>
-              </a:rPr>
-              <a:t>Deep Learning, Bishop, 2024</a:t>
-            </a:r>
-            <a:endParaRPr lang="it-IT" dirty="0"/>
-          </a:p>
-        </p:txBody>
-      </p:sp>
-      <p:sp>
-        <p:nvSpPr>
-          <p:cNvPr id="2" name="CasellaDiTesto 1">
-            <a:extLst>
-              <a:ext uri="{FF2B5EF4-FFF2-40B4-BE49-F238E27FC236}">
-                <a16:creationId xmlns:a16="http://schemas.microsoft.com/office/drawing/2014/main" id="{6C4A8E99-ABCB-9630-77A7-0B809F92A0D4}"/>
-              </a:ext>
-            </a:extLst>
-          </p:cNvPr>
-          <p:cNvSpPr txBox="1"/>
-          <p:nvPr/>
-        </p:nvSpPr>
-        <p:spPr>
-          <a:xfrm>
-            <a:off x="7752371" y="1437272"/>
-            <a:ext cx="4027706" cy="1754326"/>
-          </a:xfrm>
-          <a:prstGeom prst="rect">
-            <a:avLst/>
-          </a:prstGeom>
-          <a:noFill/>
-        </p:spPr>
-        <p:txBody>
-          <a:bodyPr wrap="none" rtlCol="0">
-            <a:spAutoFit/>
-          </a:bodyPr>
-          <a:lstStyle/>
-          <a:p>
-            <a:r>
-              <a:rPr lang="it-IT" dirty="0" err="1"/>
-              <a:t>We</a:t>
-            </a:r>
-            <a:r>
-              <a:rPr lang="it-IT" dirty="0"/>
-              <a:t> can </a:t>
-            </a:r>
-            <a:r>
-              <a:rPr lang="it-IT" dirty="0" err="1"/>
-              <a:t>adjust</a:t>
-            </a:r>
-            <a:r>
-              <a:rPr lang="it-IT" dirty="0"/>
-              <a:t> (set) </a:t>
-            </a:r>
-            <a:r>
-              <a:rPr lang="it-IT" dirty="0" err="1"/>
-              <a:t>these</a:t>
-            </a:r>
-            <a:r>
-              <a:rPr lang="it-IT" dirty="0"/>
-              <a:t> </a:t>
-            </a:r>
-            <a:r>
-              <a:rPr lang="it-IT" dirty="0" err="1"/>
-              <a:t>parameters</a:t>
-            </a:r>
-            <a:endParaRPr lang="it-IT" dirty="0"/>
-          </a:p>
-          <a:p>
-            <a:endParaRPr lang="it-IT" dirty="0"/>
-          </a:p>
-          <a:p>
-            <a:pPr marL="285750" indent="-285750">
-              <a:buFont typeface="Arial" panose="020B0604020202020204" pitchFamily="34" charset="0"/>
-              <a:buChar char="•"/>
-            </a:pPr>
-            <a:r>
-              <a:rPr lang="it-IT" dirty="0"/>
-              <a:t>Kernel size</a:t>
-            </a:r>
-          </a:p>
-          <a:p>
-            <a:pPr marL="285750" indent="-285750">
-              <a:buFont typeface="Arial" panose="020B0604020202020204" pitchFamily="34" charset="0"/>
-              <a:buChar char="•"/>
-            </a:pPr>
-            <a:r>
-              <a:rPr lang="it-IT" dirty="0"/>
-              <a:t>Number of kernels (</a:t>
-            </a:r>
-            <a:r>
-              <a:rPr lang="it-IT" dirty="0" err="1"/>
-              <a:t>maps</a:t>
-            </a:r>
-            <a:r>
-              <a:rPr lang="it-IT" dirty="0"/>
-              <a:t>)</a:t>
-            </a:r>
-          </a:p>
-          <a:p>
-            <a:pPr marL="285750" indent="-285750">
-              <a:buFont typeface="Arial" panose="020B0604020202020204" pitchFamily="34" charset="0"/>
-              <a:buChar char="•"/>
-            </a:pPr>
-            <a:r>
-              <a:rPr lang="it-IT" dirty="0" err="1"/>
-              <a:t>Activaction</a:t>
-            </a:r>
-            <a:r>
-              <a:rPr lang="it-IT" dirty="0"/>
-              <a:t> </a:t>
-            </a:r>
-            <a:r>
-              <a:rPr lang="it-IT" dirty="0" err="1"/>
-              <a:t>function</a:t>
-            </a:r>
-            <a:endParaRPr lang="it-IT" dirty="0"/>
-          </a:p>
-          <a:p>
-            <a:endParaRPr lang="it-IT" dirty="0"/>
-          </a:p>
-        </p:txBody>
-      </p:sp>
-    </p:spTree>
-    <p:extLst>
-      <p:ext uri="{BB962C8B-B14F-4D97-AF65-F5344CB8AC3E}">
-        <p14:creationId xmlns:p14="http://schemas.microsoft.com/office/powerpoint/2010/main" val="2827602021"/>
-      </p:ext>
-    </p:extLst>
-  </p:cSld>
-  <p:clrMapOvr>
-    <a:masterClrMapping/>
-  </p:clrMapOvr>
-  <p:timing>
-    <p:tnLst>
-      <p:par>
-        <p:cTn id="1" dur="indefinite" restart="never" nodeType="tmRoot">
-          <p:childTnLst>
-            <p:seq concurrent="1" nextAc="seek">
-              <p:cTn id="2" dur="indefinite" nodeType="mainSeq">
-                <p:childTnLst>
-                  <p:par>
-                    <p:cTn id="3" fill="hold">
-                      <p:stCondLst>
-                        <p:cond delay="indefinite"/>
-                      </p:stCondLst>
-                      <p:childTnLst>
-                        <p:par>
-                          <p:cTn id="4" fill="hold">
-                            <p:stCondLst>
-                              <p:cond delay="0"/>
-                            </p:stCondLst>
-                            <p:childTnLst>
-                              <p:par>
-                                <p:cTn id="5" presetID="10" presetClass="entr" presetSubtype="0" fill="hold" nodeType="clickEffect">
-                                  <p:stCondLst>
-                                    <p:cond delay="0"/>
-                                  </p:stCondLst>
-                                  <p:childTnLst>
-                                    <p:set>
-                                      <p:cBhvr>
-                                        <p:cTn id="6" dur="1" fill="hold">
-                                          <p:stCondLst>
-                                            <p:cond delay="0"/>
-                                          </p:stCondLst>
-                                        </p:cTn>
-                                        <p:tgtEl>
-                                          <p:spTgt spid="5">
-                                            <p:txEl>
-                                              <p:pRg st="0" end="0"/>
-                                            </p:txEl>
-                                          </p:spTgt>
-                                        </p:tgtEl>
-                                        <p:attrNameLst>
-                                          <p:attrName>style.visibility</p:attrName>
-                                        </p:attrNameLst>
-                                      </p:cBhvr>
-                                      <p:to>
-                                        <p:strVal val="visible"/>
-                                      </p:to>
-                                    </p:set>
-                                    <p:animEffect transition="in" filter="fade">
-                                      <p:cBhvr>
-                                        <p:cTn id="7" dur="500"/>
-                                        <p:tgtEl>
-                                          <p:spTgt spid="5">
-                                            <p:txEl>
-                                              <p:pRg st="0" end="0"/>
-                                            </p:txEl>
-                                          </p:spTgt>
-                                        </p:tgtEl>
-                                      </p:cBhvr>
-                                    </p:animEffect>
-                                  </p:childTnLst>
-                                </p:cTn>
-                              </p:par>
-                            </p:childTnLst>
-                          </p:cTn>
-                        </p:par>
-                      </p:childTnLst>
-                    </p:cTn>
-                  </p:par>
-                  <p:par>
-                    <p:cTn id="8" fill="hold">
-                      <p:stCondLst>
-                        <p:cond delay="indefinite"/>
-                      </p:stCondLst>
-                      <p:childTnLst>
-                        <p:par>
-                          <p:cTn id="9" fill="hold">
-                            <p:stCondLst>
-                              <p:cond delay="0"/>
-                            </p:stCondLst>
-                            <p:childTnLst>
-                              <p:par>
-                                <p:cTn id="10" presetID="10" presetClass="entr" presetSubtype="0" fill="hold" nodeType="clickEffect">
-                                  <p:stCondLst>
-                                    <p:cond delay="0"/>
-                                  </p:stCondLst>
-                                  <p:childTnLst>
-                                    <p:set>
-                                      <p:cBhvr>
-                                        <p:cTn id="11" dur="1" fill="hold">
-                                          <p:stCondLst>
-                                            <p:cond delay="0"/>
-                                          </p:stCondLst>
-                                        </p:cTn>
-                                        <p:tgtEl>
-                                          <p:spTgt spid="5">
-                                            <p:txEl>
-                                              <p:pRg st="2" end="2"/>
-                                            </p:txEl>
-                                          </p:spTgt>
-                                        </p:tgtEl>
-                                        <p:attrNameLst>
-                                          <p:attrName>style.visibility</p:attrName>
-                                        </p:attrNameLst>
-                                      </p:cBhvr>
-                                      <p:to>
-                                        <p:strVal val="visible"/>
-                                      </p:to>
-                                    </p:set>
-                                    <p:animEffect transition="in" filter="fade">
-                                      <p:cBhvr>
-                                        <p:cTn id="12" dur="500"/>
-                                        <p:tgtEl>
-                                          <p:spTgt spid="5">
-                                            <p:txEl>
-                                              <p:pRg st="2" end="2"/>
-                                            </p:txEl>
-                                          </p:spTgt>
-                                        </p:tgtEl>
-                                      </p:cBhvr>
-                                    </p:animEffect>
-                                  </p:childTnLst>
-                                </p:cTn>
-                              </p:par>
-                              <p:par>
-                                <p:cTn id="13" presetID="10" presetClass="entr" presetSubtype="0" fill="hold" nodeType="withEffect">
-                                  <p:stCondLst>
-                                    <p:cond delay="0"/>
-                                  </p:stCondLst>
-                                  <p:childTnLst>
-                                    <p:set>
-                                      <p:cBhvr>
-                                        <p:cTn id="14" dur="1" fill="hold">
-                                          <p:stCondLst>
-                                            <p:cond delay="0"/>
-                                          </p:stCondLst>
-                                        </p:cTn>
-                                        <p:tgtEl>
-                                          <p:spTgt spid="5">
-                                            <p:txEl>
-                                              <p:pRg st="3" end="3"/>
-                                            </p:txEl>
-                                          </p:spTgt>
-                                        </p:tgtEl>
-                                        <p:attrNameLst>
-                                          <p:attrName>style.visibility</p:attrName>
-                                        </p:attrNameLst>
-                                      </p:cBhvr>
-                                      <p:to>
-                                        <p:strVal val="visible"/>
-                                      </p:to>
-                                    </p:set>
-                                    <p:animEffect transition="in" filter="fade">
-                                      <p:cBhvr>
-                                        <p:cTn id="15" dur="500"/>
-                                        <p:tgtEl>
-                                          <p:spTgt spid="5">
-                                            <p:txEl>
-                                              <p:pRg st="3" end="3"/>
-                                            </p:txEl>
-                                          </p:spTgt>
-                                        </p:tgtEl>
-                                      </p:cBhvr>
-                                    </p:animEffect>
-                                  </p:childTnLst>
-                                </p:cTn>
-                              </p:par>
-                            </p:childTnLst>
-                          </p:cTn>
-                        </p:par>
-                      </p:childTnLst>
-                    </p:cTn>
-                  </p:par>
-                </p:childTnLst>
-              </p:cTn>
-              <p:prevCondLst>
-                <p:cond evt="onPrev" delay="0">
-                  <p:tgtEl>
-                    <p:sldTgt/>
-                  </p:tgtEl>
-                </p:cond>
-              </p:prevCondLst>
-              <p:nextCondLst>
-                <p:cond evt="onNext" delay="0">
-                  <p:tgtEl>
-                    <p:sldTgt/>
-                  </p:tgtEl>
-                </p:cond>
-              </p:nextCondLst>
-            </p:seq>
-          </p:childTnLst>
-        </p:cTn>
-      </p:par>
-    </p:tnLst>
-  </p:timing>
-</p:sld>
-</file>
-
-<file path=ppt/slides/slide13.xml><?xml version="1.0" encoding="utf-8"?>
+<file path=ppt/slides/slide11.xml><?xml version="1.0" encoding="utf-8"?>
 <p:sld xmlns:a="http://schemas.openxmlformats.org/drawingml/2006/main" xmlns:r="http://schemas.openxmlformats.org/officeDocument/2006/relationships" xmlns:p="http://schemas.openxmlformats.org/presentationml/2006/main">
   <p:cSld>
     <p:spTree>
@@ -8248,7 +7029,7 @@
 </p:sld>
 </file>
 
-<file path=ppt/slides/slide14.xml><?xml version="1.0" encoding="utf-8"?>
+<file path=ppt/slides/slide12.xml><?xml version="1.0" encoding="utf-8"?>
 <p:sld xmlns:a="http://schemas.openxmlformats.org/drawingml/2006/main" xmlns:r="http://schemas.openxmlformats.org/officeDocument/2006/relationships" xmlns:p="http://schemas.openxmlformats.org/presentationml/2006/main">
   <p:cSld>
     <p:spTree>
@@ -9805,6 +8586,770 @@
       <p:bldP spid="11" grpId="0" animBg="1"/>
       <p:bldP spid="27" grpId="0" animBg="1"/>
     </p:bldLst>
+  </p:timing>
+</p:sld>
+</file>
+
+<file path=ppt/slides/slide13.xml><?xml version="1.0" encoding="utf-8"?>
+<p:sld xmlns:a="http://schemas.openxmlformats.org/drawingml/2006/main" xmlns:r="http://schemas.openxmlformats.org/officeDocument/2006/relationships" xmlns:p="http://schemas.openxmlformats.org/presentationml/2006/main" show="0">
+  <p:cSld>
+    <p:spTree>
+      <p:nvGrpSpPr>
+        <p:cNvPr id="1" name=""/>
+        <p:cNvGrpSpPr/>
+        <p:nvPr/>
+      </p:nvGrpSpPr>
+      <p:grpSpPr>
+        <a:xfrm>
+          <a:off x="0" y="0"/>
+          <a:ext cx="0" cy="0"/>
+          <a:chOff x="0" y="0"/>
+          <a:chExt cx="0" cy="0"/>
+        </a:xfrm>
+      </p:grpSpPr>
+      <p:pic>
+        <p:nvPicPr>
+          <p:cNvPr id="9" name="Immagine 8">
+            <a:extLst>
+              <a:ext uri="{FF2B5EF4-FFF2-40B4-BE49-F238E27FC236}">
+                <a16:creationId xmlns:a16="http://schemas.microsoft.com/office/drawing/2014/main" id="{426D9FD0-5E7A-806F-7738-F5C179FB2CE4}"/>
+              </a:ext>
+            </a:extLst>
+          </p:cNvPr>
+          <p:cNvPicPr>
+            <a:picLocks noChangeAspect="1"/>
+          </p:cNvPicPr>
+          <p:nvPr/>
+        </p:nvPicPr>
+        <p:blipFill>
+          <a:blip r:embed="rId2">
+            <a:extLst>
+              <a:ext uri="{28A0092B-C50C-407E-A947-70E740481C1C}">
+                <a14:useLocalDpi xmlns:a14="http://schemas.microsoft.com/office/drawing/2010/main" val="0"/>
+              </a:ext>
+            </a:extLst>
+          </a:blip>
+          <a:stretch>
+            <a:fillRect/>
+          </a:stretch>
+        </p:blipFill>
+        <p:spPr>
+          <a:xfrm>
+            <a:off x="1202038" y="1039929"/>
+            <a:ext cx="5433531" cy="3101609"/>
+          </a:xfrm>
+          <a:prstGeom prst="rect">
+            <a:avLst/>
+          </a:prstGeom>
+        </p:spPr>
+      </p:pic>
+      <mc:AlternateContent xmlns:mc="http://schemas.openxmlformats.org/markup-compatibility/2006" xmlns:a14="http://schemas.microsoft.com/office/drawing/2010/main">
+        <mc:Choice Requires="a14">
+          <p:sp>
+            <p:nvSpPr>
+              <p:cNvPr id="5" name="CasellaDiTesto 4">
+                <a:extLst>
+                  <a:ext uri="{FF2B5EF4-FFF2-40B4-BE49-F238E27FC236}">
+                    <a16:creationId xmlns:a16="http://schemas.microsoft.com/office/drawing/2014/main" id="{DE26804E-933A-AEFF-94B0-1FF2B1F505FE}"/>
+                  </a:ext>
+                </a:extLst>
+              </p:cNvPr>
+              <p:cNvSpPr txBox="1"/>
+              <p:nvPr/>
+            </p:nvSpPr>
+            <p:spPr>
+              <a:xfrm>
+                <a:off x="1592795" y="4204527"/>
+                <a:ext cx="7121934" cy="1815882"/>
+              </a:xfrm>
+              <a:prstGeom prst="rect">
+                <a:avLst/>
+              </a:prstGeom>
+              <a:noFill/>
+            </p:spPr>
+            <p:txBody>
+              <a:bodyPr wrap="square" rtlCol="0">
+                <a:spAutoFit/>
+              </a:bodyPr>
+              <a:lstStyle/>
+              <a:p>
+                <a:pPr marL="342900" indent="-342900">
+                  <a:buFont typeface="Arial" panose="020B0604020202020204" pitchFamily="34" charset="0"/>
+                  <a:buChar char="•"/>
+                </a:pPr>
+                <a:r>
+                  <a:rPr lang="en-PH" sz="2400" b="1" dirty="0"/>
+                  <a:t>Sparse connectivity </a:t>
+                </a:r>
+                <a:r>
+                  <a:rPr lang="en-PH" sz="2400" dirty="0"/>
+                  <a:t>-</a:t>
+                </a:r>
+                <a:r>
+                  <a:rPr lang="en-PH" sz="2000" dirty="0"/>
+                  <a:t>&gt; retrieve spatial information</a:t>
+                </a:r>
+                <a:endParaRPr lang="en-PH" sz="2400" dirty="0"/>
+              </a:p>
+              <a:p>
+                <a:endParaRPr lang="en-PH" sz="2400" b="1" dirty="0"/>
+              </a:p>
+              <a:p>
+                <a:pPr marL="342900" indent="-342900">
+                  <a:buFont typeface="Arial" panose="020B0604020202020204" pitchFamily="34" charset="0"/>
+                  <a:buChar char="•"/>
+                </a:pPr>
+                <a:r>
+                  <a:rPr lang="en-PH" sz="2400" b="1" dirty="0"/>
+                  <a:t>Weight sharing </a:t>
+                </a:r>
+                <a:r>
+                  <a:rPr lang="en-PH" sz="2400" dirty="0"/>
+                  <a:t>-------</a:t>
+                </a:r>
+                <a:r>
+                  <a:rPr lang="en-PH" sz="2000" dirty="0"/>
+                  <a:t>&gt; Translational invariance</a:t>
+                </a:r>
+              </a:p>
+              <a:p>
+                <a:pPr lvl="1"/>
+                <a:r>
+                  <a:rPr lang="en-PH" sz="2000" dirty="0"/>
+                  <a:t>    (</a:t>
+                </a:r>
+                <a14:m>
+                  <m:oMath xmlns:m="http://schemas.openxmlformats.org/officeDocument/2006/math">
+                    <m:sSub>
+                      <m:sSubPr>
+                        <m:ctrlPr>
+                          <a:rPr lang="it-IT" sz="2000" i="1">
+                            <a:latin typeface="Cambria Math" panose="02040503050406030204" pitchFamily="18" charset="0"/>
+                          </a:rPr>
+                        </m:ctrlPr>
+                      </m:sSubPr>
+                      <m:e>
+                        <m:r>
+                          <a:rPr lang="it-IT" sz="2000" i="1">
+                            <a:latin typeface="Cambria Math" panose="02040503050406030204" pitchFamily="18" charset="0"/>
+                          </a:rPr>
+                          <m:t>𝑤</m:t>
+                        </m:r>
+                      </m:e>
+                      <m:sub>
+                        <m:r>
+                          <a:rPr lang="it-IT" sz="2000" i="1">
+                            <a:latin typeface="Cambria Math" panose="02040503050406030204" pitchFamily="18" charset="0"/>
+                          </a:rPr>
+                          <m:t>1</m:t>
+                        </m:r>
+                      </m:sub>
+                    </m:sSub>
+                    <m:r>
+                      <a:rPr lang="it-IT" sz="2000" i="1">
+                        <a:latin typeface="Cambria Math" panose="02040503050406030204" pitchFamily="18" charset="0"/>
+                      </a:rPr>
+                      <m:t>=</m:t>
+                    </m:r>
+                    <m:sSub>
+                      <m:sSubPr>
+                        <m:ctrlPr>
+                          <a:rPr lang="it-IT" sz="2000" i="1">
+                            <a:latin typeface="Cambria Math" panose="02040503050406030204" pitchFamily="18" charset="0"/>
+                          </a:rPr>
+                        </m:ctrlPr>
+                      </m:sSubPr>
+                      <m:e>
+                        <m:r>
+                          <a:rPr lang="it-IT" sz="2000" i="1">
+                            <a:latin typeface="Cambria Math" panose="02040503050406030204" pitchFamily="18" charset="0"/>
+                          </a:rPr>
+                          <m:t>𝑤</m:t>
+                        </m:r>
+                      </m:e>
+                      <m:sub>
+                        <m:r>
+                          <a:rPr lang="it-IT" sz="2000" i="1">
+                            <a:latin typeface="Cambria Math" panose="02040503050406030204" pitchFamily="18" charset="0"/>
+                          </a:rPr>
+                          <m:t>2</m:t>
+                        </m:r>
+                      </m:sub>
+                    </m:sSub>
+                  </m:oMath>
+                </a14:m>
+                <a:r>
+                  <a:rPr lang="en-PH" sz="2000" dirty="0"/>
+                  <a:t>)</a:t>
+                </a:r>
+                <a:endParaRPr lang="it-IT" sz="2000" dirty="0"/>
+              </a:p>
+              <a:p>
+                <a:pPr lvl="1"/>
+                <a:endParaRPr lang="en-PH" sz="2000" dirty="0"/>
+              </a:p>
+            </p:txBody>
+          </p:sp>
+        </mc:Choice>
+        <mc:Fallback xmlns="">
+          <p:sp>
+            <p:nvSpPr>
+              <p:cNvPr id="5" name="CasellaDiTesto 4">
+                <a:extLst>
+                  <a:ext uri="{FF2B5EF4-FFF2-40B4-BE49-F238E27FC236}">
+                    <a16:creationId xmlns:a16="http://schemas.microsoft.com/office/drawing/2014/main" id="{DE26804E-933A-AEFF-94B0-1FF2B1F505FE}"/>
+                  </a:ext>
+                </a:extLst>
+              </p:cNvPr>
+              <p:cNvSpPr txBox="1">
+                <a:spLocks noRot="1" noChangeAspect="1" noMove="1" noResize="1" noEditPoints="1" noAdjustHandles="1" noChangeArrowheads="1" noChangeShapeType="1" noTextEdit="1"/>
+              </p:cNvSpPr>
+              <p:nvPr/>
+            </p:nvSpPr>
+            <p:spPr>
+              <a:xfrm>
+                <a:off x="1592795" y="4204527"/>
+                <a:ext cx="7121934" cy="1815882"/>
+              </a:xfrm>
+              <a:prstGeom prst="rect">
+                <a:avLst/>
+              </a:prstGeom>
+              <a:blipFill>
+                <a:blip r:embed="rId3"/>
+                <a:stretch>
+                  <a:fillRect l="-1112" t="-2349"/>
+                </a:stretch>
+              </a:blipFill>
+            </p:spPr>
+            <p:txBody>
+              <a:bodyPr/>
+              <a:lstStyle/>
+              <a:p>
+                <a:r>
+                  <a:rPr lang="it-IT">
+                    <a:noFill/>
+                  </a:rPr>
+                  <a:t> </a:t>
+                </a:r>
+              </a:p>
+            </p:txBody>
+          </p:sp>
+        </mc:Fallback>
+      </mc:AlternateContent>
+      <mc:AlternateContent xmlns:mc="http://schemas.openxmlformats.org/markup-compatibility/2006" xmlns:a14="http://schemas.microsoft.com/office/drawing/2010/main">
+        <mc:Choice Requires="a14">
+          <p:sp>
+            <p:nvSpPr>
+              <p:cNvPr id="19" name="CasellaDiTesto 18">
+                <a:extLst>
+                  <a:ext uri="{FF2B5EF4-FFF2-40B4-BE49-F238E27FC236}">
+                    <a16:creationId xmlns:a16="http://schemas.microsoft.com/office/drawing/2014/main" id="{BF2604CA-475F-259C-6DDC-F1F5D1F66FA5}"/>
+                  </a:ext>
+                </a:extLst>
+              </p:cNvPr>
+              <p:cNvSpPr txBox="1"/>
+              <p:nvPr/>
+            </p:nvSpPr>
+            <p:spPr>
+              <a:xfrm>
+                <a:off x="2254112" y="2668378"/>
+                <a:ext cx="567783" cy="523220"/>
+              </a:xfrm>
+              <a:prstGeom prst="rect">
+                <a:avLst/>
+              </a:prstGeom>
+              <a:noFill/>
+            </p:spPr>
+            <p:txBody>
+              <a:bodyPr wrap="none" rtlCol="0">
+                <a:spAutoFit/>
+              </a:bodyPr>
+              <a:lstStyle/>
+              <a:p>
+                <a:pPr/>
+                <a14:m>
+                  <m:oMathPara xmlns:m="http://schemas.openxmlformats.org/officeDocument/2006/math">
+                    <m:oMathParaPr>
+                      <m:jc m:val="centerGroup"/>
+                    </m:oMathParaPr>
+                    <m:oMath xmlns:m="http://schemas.openxmlformats.org/officeDocument/2006/math">
+                      <m:r>
+                        <a:rPr lang="it-IT" sz="2800" b="1" i="1" smtClean="0">
+                          <a:solidFill>
+                            <a:srgbClr val="1F4291"/>
+                          </a:solidFill>
+                          <a:latin typeface="Cambria Math" panose="02040503050406030204" pitchFamily="18" charset="0"/>
+                        </a:rPr>
+                        <m:t>𝒘</m:t>
+                      </m:r>
+                    </m:oMath>
+                  </m:oMathPara>
+                </a14:m>
+                <a:endParaRPr lang="it-IT" b="1" dirty="0">
+                  <a:solidFill>
+                    <a:srgbClr val="1F4291"/>
+                  </a:solidFill>
+                </a:endParaRPr>
+              </a:p>
+            </p:txBody>
+          </p:sp>
+        </mc:Choice>
+        <mc:Fallback xmlns="">
+          <p:sp>
+            <p:nvSpPr>
+              <p:cNvPr id="19" name="CasellaDiTesto 18">
+                <a:extLst>
+                  <a:ext uri="{FF2B5EF4-FFF2-40B4-BE49-F238E27FC236}">
+                    <a16:creationId xmlns:a16="http://schemas.microsoft.com/office/drawing/2014/main" id="{BF2604CA-475F-259C-6DDC-F1F5D1F66FA5}"/>
+                  </a:ext>
+                </a:extLst>
+              </p:cNvPr>
+              <p:cNvSpPr txBox="1">
+                <a:spLocks noRot="1" noChangeAspect="1" noMove="1" noResize="1" noEditPoints="1" noAdjustHandles="1" noChangeArrowheads="1" noChangeShapeType="1" noTextEdit="1"/>
+              </p:cNvSpPr>
+              <p:nvPr/>
+            </p:nvSpPr>
+            <p:spPr>
+              <a:xfrm>
+                <a:off x="2254112" y="2668378"/>
+                <a:ext cx="567783" cy="523220"/>
+              </a:xfrm>
+              <a:prstGeom prst="rect">
+                <a:avLst/>
+              </a:prstGeom>
+              <a:blipFill>
+                <a:blip r:embed="rId4"/>
+                <a:stretch>
+                  <a:fillRect/>
+                </a:stretch>
+              </a:blipFill>
+            </p:spPr>
+            <p:txBody>
+              <a:bodyPr/>
+              <a:lstStyle/>
+              <a:p>
+                <a:r>
+                  <a:rPr lang="it-IT">
+                    <a:noFill/>
+                  </a:rPr>
+                  <a:t> </a:t>
+                </a:r>
+              </a:p>
+            </p:txBody>
+          </p:sp>
+        </mc:Fallback>
+      </mc:AlternateContent>
+      <p:sp>
+        <p:nvSpPr>
+          <p:cNvPr id="23" name="CasellaDiTesto 22">
+            <a:extLst>
+              <a:ext uri="{FF2B5EF4-FFF2-40B4-BE49-F238E27FC236}">
+                <a16:creationId xmlns:a16="http://schemas.microsoft.com/office/drawing/2014/main" id="{B6577D95-5E14-FE86-3DAE-77C5FC179719}"/>
+              </a:ext>
+            </a:extLst>
+          </p:cNvPr>
+          <p:cNvSpPr txBox="1"/>
+          <p:nvPr/>
+        </p:nvSpPr>
+        <p:spPr>
+          <a:xfrm>
+            <a:off x="0" y="350575"/>
+            <a:ext cx="12192000" cy="830997"/>
+          </a:xfrm>
+          <a:prstGeom prst="rect">
+            <a:avLst/>
+          </a:prstGeom>
+          <a:noFill/>
+        </p:spPr>
+        <p:txBody>
+          <a:bodyPr wrap="square" rtlCol="0">
+            <a:spAutoFit/>
+          </a:bodyPr>
+          <a:lstStyle/>
+          <a:p>
+            <a:pPr algn="ctr"/>
+            <a:r>
+              <a:rPr lang="en-PH" sz="2400" dirty="0"/>
+              <a:t>Convolutional Neural </a:t>
+            </a:r>
+            <a:r>
+              <a:rPr lang="en-PH" sz="2400" dirty="0" err="1"/>
+              <a:t>Netowrks</a:t>
+            </a:r>
+            <a:endParaRPr lang="en-PH" sz="2400" dirty="0"/>
+          </a:p>
+          <a:p>
+            <a:pPr algn="ctr"/>
+            <a:r>
+              <a:rPr lang="en-PH" sz="2400" dirty="0"/>
+              <a:t>(CNNs)</a:t>
+            </a:r>
+            <a:endParaRPr lang="en-PH" sz="2000" dirty="0"/>
+          </a:p>
+        </p:txBody>
+      </p:sp>
+      <p:sp>
+        <p:nvSpPr>
+          <p:cNvPr id="4" name="CasellaDiTesto 3">
+            <a:extLst>
+              <a:ext uri="{FF2B5EF4-FFF2-40B4-BE49-F238E27FC236}">
+                <a16:creationId xmlns:a16="http://schemas.microsoft.com/office/drawing/2014/main" id="{6DD8B2EA-EBF4-A2B5-87A3-3B5D812DB12C}"/>
+              </a:ext>
+            </a:extLst>
+          </p:cNvPr>
+          <p:cNvSpPr txBox="1"/>
+          <p:nvPr/>
+        </p:nvSpPr>
+        <p:spPr>
+          <a:xfrm>
+            <a:off x="184961" y="6020409"/>
+            <a:ext cx="3172663" cy="646331"/>
+          </a:xfrm>
+          <a:prstGeom prst="rect">
+            <a:avLst/>
+          </a:prstGeom>
+          <a:noFill/>
+        </p:spPr>
+        <p:txBody>
+          <a:bodyPr wrap="none" rtlCol="0">
+            <a:spAutoFit/>
+          </a:bodyPr>
+          <a:lstStyle/>
+          <a:p>
+            <a:pPr algn="ctr"/>
+            <a:r>
+              <a:rPr lang="it-IT" dirty="0"/>
+              <a:t>Book</a:t>
+            </a:r>
+          </a:p>
+          <a:p>
+            <a:r>
+              <a:rPr lang="it-IT" dirty="0">
+                <a:hlinkClick r:id="rId5"/>
+              </a:rPr>
+              <a:t>Deep Learning, Bishop, 2024</a:t>
+            </a:r>
+            <a:endParaRPr lang="it-IT" dirty="0"/>
+          </a:p>
+        </p:txBody>
+      </p:sp>
+      <p:sp>
+        <p:nvSpPr>
+          <p:cNvPr id="2" name="CasellaDiTesto 1">
+            <a:extLst>
+              <a:ext uri="{FF2B5EF4-FFF2-40B4-BE49-F238E27FC236}">
+                <a16:creationId xmlns:a16="http://schemas.microsoft.com/office/drawing/2014/main" id="{6C4A8E99-ABCB-9630-77A7-0B809F92A0D4}"/>
+              </a:ext>
+            </a:extLst>
+          </p:cNvPr>
+          <p:cNvSpPr txBox="1"/>
+          <p:nvPr/>
+        </p:nvSpPr>
+        <p:spPr>
+          <a:xfrm>
+            <a:off x="7752371" y="1437272"/>
+            <a:ext cx="4027706" cy="1754326"/>
+          </a:xfrm>
+          <a:prstGeom prst="rect">
+            <a:avLst/>
+          </a:prstGeom>
+          <a:noFill/>
+        </p:spPr>
+        <p:txBody>
+          <a:bodyPr wrap="none" rtlCol="0">
+            <a:spAutoFit/>
+          </a:bodyPr>
+          <a:lstStyle/>
+          <a:p>
+            <a:r>
+              <a:rPr lang="it-IT" dirty="0" err="1"/>
+              <a:t>We</a:t>
+            </a:r>
+            <a:r>
+              <a:rPr lang="it-IT" dirty="0"/>
+              <a:t> can </a:t>
+            </a:r>
+            <a:r>
+              <a:rPr lang="it-IT" dirty="0" err="1"/>
+              <a:t>adjust</a:t>
+            </a:r>
+            <a:r>
+              <a:rPr lang="it-IT" dirty="0"/>
+              <a:t> (set) </a:t>
+            </a:r>
+            <a:r>
+              <a:rPr lang="it-IT" dirty="0" err="1"/>
+              <a:t>these</a:t>
+            </a:r>
+            <a:r>
+              <a:rPr lang="it-IT" dirty="0"/>
+              <a:t> </a:t>
+            </a:r>
+            <a:r>
+              <a:rPr lang="it-IT" dirty="0" err="1"/>
+              <a:t>parameters</a:t>
+            </a:r>
+            <a:endParaRPr lang="it-IT" dirty="0"/>
+          </a:p>
+          <a:p>
+            <a:endParaRPr lang="it-IT" dirty="0"/>
+          </a:p>
+          <a:p>
+            <a:pPr marL="285750" indent="-285750">
+              <a:buFont typeface="Arial" panose="020B0604020202020204" pitchFamily="34" charset="0"/>
+              <a:buChar char="•"/>
+            </a:pPr>
+            <a:r>
+              <a:rPr lang="it-IT" dirty="0"/>
+              <a:t>Kernel size</a:t>
+            </a:r>
+          </a:p>
+          <a:p>
+            <a:pPr marL="285750" indent="-285750">
+              <a:buFont typeface="Arial" panose="020B0604020202020204" pitchFamily="34" charset="0"/>
+              <a:buChar char="•"/>
+            </a:pPr>
+            <a:r>
+              <a:rPr lang="it-IT" dirty="0"/>
+              <a:t>Number of kernels (</a:t>
+            </a:r>
+            <a:r>
+              <a:rPr lang="it-IT" dirty="0" err="1"/>
+              <a:t>maps</a:t>
+            </a:r>
+            <a:r>
+              <a:rPr lang="it-IT" dirty="0"/>
+              <a:t>)</a:t>
+            </a:r>
+          </a:p>
+          <a:p>
+            <a:pPr marL="285750" indent="-285750">
+              <a:buFont typeface="Arial" panose="020B0604020202020204" pitchFamily="34" charset="0"/>
+              <a:buChar char="•"/>
+            </a:pPr>
+            <a:r>
+              <a:rPr lang="it-IT" dirty="0" err="1"/>
+              <a:t>Activaction</a:t>
+            </a:r>
+            <a:r>
+              <a:rPr lang="it-IT" dirty="0"/>
+              <a:t> </a:t>
+            </a:r>
+            <a:r>
+              <a:rPr lang="it-IT" dirty="0" err="1"/>
+              <a:t>function</a:t>
+            </a:r>
+            <a:endParaRPr lang="it-IT" dirty="0"/>
+          </a:p>
+          <a:p>
+            <a:endParaRPr lang="it-IT" dirty="0"/>
+          </a:p>
+        </p:txBody>
+      </p:sp>
+    </p:spTree>
+    <p:extLst>
+      <p:ext uri="{BB962C8B-B14F-4D97-AF65-F5344CB8AC3E}">
+        <p14:creationId xmlns:p14="http://schemas.microsoft.com/office/powerpoint/2010/main" val="2827602021"/>
+      </p:ext>
+    </p:extLst>
+  </p:cSld>
+  <p:clrMapOvr>
+    <a:masterClrMapping/>
+  </p:clrMapOvr>
+  <p:timing>
+    <p:tnLst>
+      <p:par>
+        <p:cTn id="1" dur="indefinite" restart="never" nodeType="tmRoot">
+          <p:childTnLst>
+            <p:seq concurrent="1" nextAc="seek">
+              <p:cTn id="2" dur="indefinite" nodeType="mainSeq">
+                <p:childTnLst>
+                  <p:par>
+                    <p:cTn id="3" fill="hold">
+                      <p:stCondLst>
+                        <p:cond delay="indefinite"/>
+                      </p:stCondLst>
+                      <p:childTnLst>
+                        <p:par>
+                          <p:cTn id="4" fill="hold">
+                            <p:stCondLst>
+                              <p:cond delay="0"/>
+                            </p:stCondLst>
+                            <p:childTnLst>
+                              <p:par>
+                                <p:cTn id="5" presetID="10" presetClass="entr" presetSubtype="0" fill="hold" nodeType="clickEffect">
+                                  <p:stCondLst>
+                                    <p:cond delay="0"/>
+                                  </p:stCondLst>
+                                  <p:childTnLst>
+                                    <p:set>
+                                      <p:cBhvr>
+                                        <p:cTn id="6" dur="1" fill="hold">
+                                          <p:stCondLst>
+                                            <p:cond delay="0"/>
+                                          </p:stCondLst>
+                                        </p:cTn>
+                                        <p:tgtEl>
+                                          <p:spTgt spid="5">
+                                            <p:txEl>
+                                              <p:pRg st="0" end="0"/>
+                                            </p:txEl>
+                                          </p:spTgt>
+                                        </p:tgtEl>
+                                        <p:attrNameLst>
+                                          <p:attrName>style.visibility</p:attrName>
+                                        </p:attrNameLst>
+                                      </p:cBhvr>
+                                      <p:to>
+                                        <p:strVal val="visible"/>
+                                      </p:to>
+                                    </p:set>
+                                    <p:animEffect transition="in" filter="fade">
+                                      <p:cBhvr>
+                                        <p:cTn id="7" dur="500"/>
+                                        <p:tgtEl>
+                                          <p:spTgt spid="5">
+                                            <p:txEl>
+                                              <p:pRg st="0" end="0"/>
+                                            </p:txEl>
+                                          </p:spTgt>
+                                        </p:tgtEl>
+                                      </p:cBhvr>
+                                    </p:animEffect>
+                                  </p:childTnLst>
+                                </p:cTn>
+                              </p:par>
+                            </p:childTnLst>
+                          </p:cTn>
+                        </p:par>
+                      </p:childTnLst>
+                    </p:cTn>
+                  </p:par>
+                  <p:par>
+                    <p:cTn id="8" fill="hold">
+                      <p:stCondLst>
+                        <p:cond delay="indefinite"/>
+                      </p:stCondLst>
+                      <p:childTnLst>
+                        <p:par>
+                          <p:cTn id="9" fill="hold">
+                            <p:stCondLst>
+                              <p:cond delay="0"/>
+                            </p:stCondLst>
+                            <p:childTnLst>
+                              <p:par>
+                                <p:cTn id="10" presetID="10" presetClass="entr" presetSubtype="0" fill="hold" nodeType="clickEffect">
+                                  <p:stCondLst>
+                                    <p:cond delay="0"/>
+                                  </p:stCondLst>
+                                  <p:childTnLst>
+                                    <p:set>
+                                      <p:cBhvr>
+                                        <p:cTn id="11" dur="1" fill="hold">
+                                          <p:stCondLst>
+                                            <p:cond delay="0"/>
+                                          </p:stCondLst>
+                                        </p:cTn>
+                                        <p:tgtEl>
+                                          <p:spTgt spid="5">
+                                            <p:txEl>
+                                              <p:pRg st="2" end="2"/>
+                                            </p:txEl>
+                                          </p:spTgt>
+                                        </p:tgtEl>
+                                        <p:attrNameLst>
+                                          <p:attrName>style.visibility</p:attrName>
+                                        </p:attrNameLst>
+                                      </p:cBhvr>
+                                      <p:to>
+                                        <p:strVal val="visible"/>
+                                      </p:to>
+                                    </p:set>
+                                    <p:animEffect transition="in" filter="fade">
+                                      <p:cBhvr>
+                                        <p:cTn id="12" dur="500"/>
+                                        <p:tgtEl>
+                                          <p:spTgt spid="5">
+                                            <p:txEl>
+                                              <p:pRg st="2" end="2"/>
+                                            </p:txEl>
+                                          </p:spTgt>
+                                        </p:tgtEl>
+                                      </p:cBhvr>
+                                    </p:animEffect>
+                                  </p:childTnLst>
+                                </p:cTn>
+                              </p:par>
+                              <p:par>
+                                <p:cTn id="13" presetID="10" presetClass="entr" presetSubtype="0" fill="hold" nodeType="withEffect">
+                                  <p:stCondLst>
+                                    <p:cond delay="0"/>
+                                  </p:stCondLst>
+                                  <p:childTnLst>
+                                    <p:set>
+                                      <p:cBhvr>
+                                        <p:cTn id="14" dur="1" fill="hold">
+                                          <p:stCondLst>
+                                            <p:cond delay="0"/>
+                                          </p:stCondLst>
+                                        </p:cTn>
+                                        <p:tgtEl>
+                                          <p:spTgt spid="5">
+                                            <p:txEl>
+                                              <p:pRg st="3" end="3"/>
+                                            </p:txEl>
+                                          </p:spTgt>
+                                        </p:tgtEl>
+                                        <p:attrNameLst>
+                                          <p:attrName>style.visibility</p:attrName>
+                                        </p:attrNameLst>
+                                      </p:cBhvr>
+                                      <p:to>
+                                        <p:strVal val="visible"/>
+                                      </p:to>
+                                    </p:set>
+                                    <p:animEffect transition="in" filter="fade">
+                                      <p:cBhvr>
+                                        <p:cTn id="15" dur="500"/>
+                                        <p:tgtEl>
+                                          <p:spTgt spid="5">
+                                            <p:txEl>
+                                              <p:pRg st="3" end="3"/>
+                                            </p:txEl>
+                                          </p:spTgt>
+                                        </p:tgtEl>
+                                      </p:cBhvr>
+                                    </p:animEffect>
+                                  </p:childTnLst>
+                                </p:cTn>
+                              </p:par>
+                            </p:childTnLst>
+                          </p:cTn>
+                        </p:par>
+                      </p:childTnLst>
+                    </p:cTn>
+                  </p:par>
+                </p:childTnLst>
+              </p:cTn>
+              <p:prevCondLst>
+                <p:cond evt="onPrev" delay="0">
+                  <p:tgtEl>
+                    <p:sldTgt/>
+                  </p:tgtEl>
+                </p:cond>
+              </p:prevCondLst>
+              <p:nextCondLst>
+                <p:cond evt="onNext" delay="0">
+                  <p:tgtEl>
+                    <p:sldTgt/>
+                  </p:tgtEl>
+                </p:cond>
+              </p:nextCondLst>
+            </p:seq>
+          </p:childTnLst>
+        </p:cTn>
+      </p:par>
+    </p:tnLst>
   </p:timing>
 </p:sld>
 </file>
@@ -26317,6 +25862,72 @@
           </a:p>
         </p:txBody>
       </p:sp>
+      <p:sp>
+        <p:nvSpPr>
+          <p:cNvPr id="3" name="CasellaDiTesto 2">
+            <a:extLst>
+              <a:ext uri="{FF2B5EF4-FFF2-40B4-BE49-F238E27FC236}">
+                <a16:creationId xmlns:a16="http://schemas.microsoft.com/office/drawing/2014/main" id="{48DEE4E9-E62C-0B83-5403-37A29051B336}"/>
+              </a:ext>
+            </a:extLst>
+          </p:cNvPr>
+          <p:cNvSpPr txBox="1"/>
+          <p:nvPr/>
+        </p:nvSpPr>
+        <p:spPr>
+          <a:xfrm>
+            <a:off x="3681463" y="5858720"/>
+            <a:ext cx="3849494" cy="646331"/>
+          </a:xfrm>
+          <a:prstGeom prst="rect">
+            <a:avLst/>
+          </a:prstGeom>
+          <a:noFill/>
+        </p:spPr>
+        <p:txBody>
+          <a:bodyPr wrap="square">
+            <a:spAutoFit/>
+          </a:bodyPr>
+          <a:lstStyle/>
+          <a:p>
+            <a:pPr algn="ctr"/>
+            <a:r>
+              <a:rPr lang="it-IT" dirty="0" err="1">
+                <a:hlinkClick r:id="rId3"/>
+              </a:rPr>
+              <a:t>Deep_Dense_ising.ipynb</a:t>
+            </a:r>
+            <a:r>
+              <a:rPr lang="it-IT" dirty="0">
+                <a:hlinkClick r:id="rId3"/>
+              </a:rPr>
+              <a:t> – </a:t>
+            </a:r>
+            <a:r>
+              <a:rPr lang="it-IT" dirty="0" err="1">
+                <a:hlinkClick r:id="rId3"/>
+              </a:rPr>
+              <a:t>Colab</a:t>
+            </a:r>
+            <a:endParaRPr lang="it-IT" dirty="0"/>
+          </a:p>
+          <a:p>
+            <a:pPr algn="ctr"/>
+            <a:r>
+              <a:rPr lang="it-IT" dirty="0"/>
+              <a:t>Code for </a:t>
+            </a:r>
+            <a:r>
+              <a:rPr lang="it-IT" dirty="0" err="1"/>
+              <a:t>this</a:t>
+            </a:r>
+            <a:r>
+              <a:rPr lang="it-IT" dirty="0"/>
+              <a:t> network</a:t>
+            </a:r>
+          </a:p>
+        </p:txBody>
+      </p:sp>
     </p:spTree>
     <p:extLst>
       <p:ext uri="{BB962C8B-B14F-4D97-AF65-F5344CB8AC3E}">

</xml_diff>